<commit_message>
Replace long dashes with hyphens across v2 deliverables
Sanitize em dash, en dash and minus sign to hyphen in all three v2
files (deck, xlsx, doc); reword '->20%' style strings to 'drops >20%'.

https://claude.ai/code/session_01NksSqrSqDgtmZbhunqjgZD
</commit_message>
<xml_diff>
--- a/outputs/touchretouch-testtask/v2/TouchRetouch_Deck.pptx
+++ b/outputs/touchretouch-testtask/v2/TouchRetouch_Deck.pptx
@@ -3308,7 +3308,7 @@
                 </a:solidFill>
                 <a:latin typeface="Calibri"/>
               </a:rPr>
-              <a:t>My thesis: stop overpaying to defend the brand, and win the users who are searching for a tool — not for a specific app. Including the ones who'd otherwise just ask an AI.</a:t>
+              <a:t>My thesis: stop overpaying to defend the brand, and win the users who are searching for a tool - not for a specific app. Including the ones who'd otherwise just ask an AI.</a:t>
             </a:r>
           </a:p>
         </p:txBody>
@@ -3583,7 +3583,7 @@
                 </a:solidFill>
                 <a:latin typeface="Calibri"/>
               </a:rPr>
-              <a:t>Days 0–30 · Stabilise</a:t>
+              <a:t>Days 0-30 · Stabilise</a:t>
             </a:r>
           </a:p>
         </p:txBody>
@@ -3670,7 +3670,7 @@
                 </a:solidFill>
                 <a:latin typeface="Calibri"/>
               </a:rPr>
-              <a:t>•  Ship 1–2 low-risk fixes; stand up weekly reporting</a:t>
+              <a:t>•  Ship 1-2 low-risk fixes; stand up weekly reporting</a:t>
             </a:r>
           </a:p>
         </p:txBody>
@@ -3727,7 +3727,7 @@
                 </a:solidFill>
                 <a:latin typeface="Calibri"/>
               </a:rPr>
-              <a:t>Days 30–60 · Rebuild</a:t>
+              <a:t>Days 30-60 · Rebuild</a:t>
             </a:r>
           </a:p>
         </p:txBody>
@@ -3798,7 +3798,7 @@
                 </a:solidFill>
                 <a:latin typeface="Calibri"/>
               </a:rPr>
-              <a:t>•  PPO on default listing; paid–organic keyword sync</a:t>
+              <a:t>•  PPO on default listing; paid-organic keyword sync</a:t>
             </a:r>
           </a:p>
           <a:p>
@@ -3871,7 +3871,7 @@
                 </a:solidFill>
                 <a:latin typeface="Calibri"/>
               </a:rPr>
-              <a:t>Days 60–90 · Scale</a:t>
+              <a:t>Days 60-90 · Scale</a:t>
             </a:r>
           </a:p>
         </p:txBody>
@@ -4238,7 +4238,7 @@
                 </a:solidFill>
                 <a:latin typeface="Calibri"/>
               </a:rPr>
-              <a:t>—  #1 assumption: revenue modelled on first-year ARPPU (same basis as the ~100% anchor). Real D30 cash = ROAS × D30/Y1 recognition — pull the curve from RevenueCat.</a:t>
+              <a:t>-  #1 assumption: revenue modelled on first-year ARPPU (same basis as the ~100% anchor). Real D30 cash = ROAS × D30/Y1 recognition - pull the curve from RevenueCat.</a:t>
             </a:r>
           </a:p>
           <a:p>
@@ -4254,7 +4254,7 @@
                 </a:solidFill>
                 <a:latin typeface="Calibri"/>
               </a:rPr>
-              <a:t>—  Brand cut: assumes organic backfills most paused brand installs. Risk: a competitor floods our brand term. Mitigate: keep a capped defensive bid + the pause test proves it.</a:t>
+              <a:t>-  Brand cut: assumes organic backfills most paused brand installs. Risk: a competitor floods our brand term. Mitigate: keep a capped defensive bid + the pause test proves it.</a:t>
             </a:r>
           </a:p>
           <a:p>
@@ -4270,7 +4270,7 @@
                 </a:solidFill>
                 <a:latin typeface="Calibri"/>
               </a:rPr>
-              <a:t>—  AI positioning is a bet: it may not convert better yet. Mitigate: test it as a contained CPP with its own kill criteria before scaling budget into it.</a:t>
+              <a:t>-  AI positioning is a bet: it may not convert better yet. Mitigate: test it as a contained CPP with its own kill criteria before scaling budget into it.</a:t>
             </a:r>
           </a:p>
           <a:p>
@@ -4286,7 +4286,7 @@
                 </a:solidFill>
                 <a:latin typeface="Calibri"/>
               </a:rPr>
-              <a:t>—  Scaling: assumes tool-intent CPT stays roughly stable at 2× spend. Risk: auction inflation / limited US volume → CPI rises. Mitigate: widen tool terms, CR gains from CPPs/PPO, tested T1 geo expansion.</a:t>
+              <a:t>-  Scaling: assumes tool-intent CPT stays roughly stable at 2× spend. Risk: auction inflation / limited US volume → CPI rises. Mitigate: widen tool terms, CR gains from CPPs/PPO, tested T1 geo expansion.</a:t>
             </a:r>
           </a:p>
           <a:p>
@@ -4302,7 +4302,7 @@
                 </a:solidFill>
                 <a:latin typeface="Calibri"/>
               </a:rPr>
-              <a:t>—  Measurement: SKAN/ATT delay &amp; nulls. Mitigate: AdServices + documented reconciliation.</a:t>
+              <a:t>-  Measurement: SKAN/ATT delay &amp; nulls. Mitigate: AdServices + documented reconciliation.</a:t>
             </a:r>
           </a:p>
         </p:txBody>
@@ -4463,7 +4463,7 @@
                 </a:solidFill>
                 <a:latin typeface="Georgia"/>
               </a:rPr>
-              <a:t>Stop overpaying to defend the brand; win the tool-intent searches with a page per tool — and the users who'd otherwise ask an AI — scaling to $70K at ≥125% by end of Q2.</a:t>
+              <a:t>Stop overpaying to defend the brand; win the tool-intent searches with a page per tool - and the users who'd otherwise ask an AI - scaling to $70K at ≥125% by end of Q2.</a:t>
             </a:r>
           </a:p>
         </p:txBody>
@@ -4874,7 +4874,7 @@
                           </a:solidFill>
                           <a:latin typeface="Calibri"/>
                         </a:rPr>
-                        <a:t>Brand overbid — 58% of spend, max €25–35 vs €1.2–1.9 real</a:t>
+                        <a:t>Brand overbid - 58% of spend, max €25-35 vs €1.2-1.9 real</a:t>
                       </a:r>
                     </a:p>
                   </a:txBody>
@@ -4918,7 +4918,7 @@
                           </a:solidFill>
                           <a:latin typeface="Calibri"/>
                         </a:rPr>
-                        <a:t>Cap brand to €3–5 + small defensive bid; move the freed budget to tool intent</a:t>
+                        <a:t>Cap brand to €3-5 + small defensive bid; move the freed budget to tool intent</a:t>
                       </a:r>
                     </a:p>
                   </a:txBody>
@@ -5144,7 +5144,7 @@
                           </a:solidFill>
                           <a:latin typeface="Calibri"/>
                         </a:rPr>
-                        <a:t>Competitor only on Product Pages — CPA €17, TTR 2%</a:t>
+                        <a:t>Competitor only on Product Pages - CPA €17, TTR 2%</a:t>
                       </a:r>
                     </a:p>
                   </a:txBody>
@@ -5234,7 +5234,7 @@
                           </a:solidFill>
                           <a:latin typeface="Calibri"/>
                         </a:rPr>
-                        <a:t>Feature campaign timid — 'magic eraser' €4–7, single-digit installs</a:t>
+                        <a:t>Feature campaign timid - 'magic eraser' €4-7, single-digit installs</a:t>
                       </a:r>
                     </a:p>
                   </a:txBody>
@@ -5545,7 +5545,7 @@
                 </a:solidFill>
                 <a:latin typeface="Calibri"/>
               </a:rPr>
-              <a:t>Competitors' names ARE their keywords — like EMD domains. But a person typing "magic eraser" or "object remover" isn't after a specific app; they want the tool. Whoever shows the best solution wins the tap. So I put the money on tool intent with a dedicated page per tool — not on defending the brand.</a:t>
+              <a:t>Competitors' names ARE their keywords - like EMD domains. But a person typing "magic eraser" or "object remover" isn't after a specific app; they want the tool. Whoever shows the best solution wins the tap. So I put the money on tool intent with a dedicated page per tool - not on defending the brand.</a:t>
             </a:r>
           </a:p>
         </p:txBody>
@@ -5641,7 +5641,7 @@
                 </a:solidFill>
                 <a:latin typeface="Calibri"/>
               </a:rPr>
-              <a:t>Exact · bid capped €3–5 + defensive</a:t>
+              <a:t>Exact · bid capped €3-5 + defensive</a:t>
             </a:r>
           </a:p>
           <a:p>
@@ -5769,7 +5769,7 @@
                 </a:solidFill>
                 <a:latin typeface="Calibri"/>
               </a:rPr>
-              <a:t>'magic eraser', 'object remover', 'background remover', 'photo retouch' — the money bucket</a:t>
+              <a:t>'magic eraser', 'object remover', 'background remover', 'photo retouch' - the money bucket</a:t>
             </a:r>
           </a:p>
         </p:txBody>
@@ -6401,7 +6401,7 @@
                 </a:solidFill>
                 <a:latin typeface="Calibri"/>
               </a:rPr>
-              <a:t>My process: seed in ASO Mobile, then pull demand from Ahrefs (Google) — search intent transfers across surfaces: what people Google, they also type in the App Store. Ahrefs is for discovering intent; I size each candidate with App Store / ASA popularity before committing, because Google volume ≠ store volume.</a:t>
+              <a:t>My process: seed in ASO Mobile, then pull demand from Ahrefs (Google) - search intent transfers across surfaces: what people Google, they also type in the App Store. Ahrefs is for discovering intent; I size each candidate with App Store / ASA popularity before committing, because Google volume ≠ store volume.</a:t>
             </a:r>
           </a:p>
         </p:txBody>
@@ -6443,7 +6443,7 @@
                           </a:solidFill>
                           <a:latin typeface="Georgia"/>
                         </a:rPr>
-                        <a:t>Brand — defend</a:t>
+                        <a:t>Brand - defend</a:t>
                       </a:r>
                     </a:p>
                   </a:txBody>
@@ -6465,7 +6465,7 @@
                           </a:solidFill>
                           <a:latin typeface="Georgia"/>
                         </a:rPr>
-                        <a:t>Generic / tool — attack</a:t>
+                        <a:t>Generic / tool - attack</a:t>
                       </a:r>
                     </a:p>
                   </a:txBody>
@@ -6509,7 +6509,7 @@
                           </a:solidFill>
                           <a:latin typeface="Georgia"/>
                         </a:rPr>
-                        <a:t>AI intent — new</a:t>
+                        <a:t>AI intent - new</a:t>
                       </a:r>
                     </a:p>
                   </a:txBody>
@@ -7008,7 +7008,7 @@
                 </a:solidFill>
                 <a:latin typeface="Calibri"/>
               </a:rPr>
-              <a:t>Match logic: exact for proven terms; Broad + Search Match isolated in Discovery to harvest. Competitor split: brandable names (Facetune/Snapseed) = weak conquest; tool-named intent = the real gold. Competitor brands are bid in ASA only — never in metadata (trademark / 2.3.7).</a:t>
+              <a:t>Match logic: exact for proven terms; Broad + Search Match isolated in Discovery to harvest. Competitor split: brandable names (Facetune/Snapseed) = weak conquest; tool-named intent = the real gold. Competitor brands are bid in ASA only - never in metadata (trademark / 2.3.7).</a:t>
             </a:r>
           </a:p>
         </p:txBody>
@@ -7265,7 +7265,7 @@
                 </a:solidFill>
                 <a:latin typeface="Calibri"/>
               </a:rPr>
-              <a:t>—  Metadata: top tool term → Subtitle; feature/tool terms + 'ai' → Keyword field; Title = TouchRetouch + top tool term.</a:t>
+              <a:t>-  Metadata: top tool term → Subtitle; feature/tool terms + 'ai' → Keyword field; Title = TouchRetouch + top tool term.</a:t>
             </a:r>
           </a:p>
           <a:p>
@@ -7281,7 +7281,7 @@
                 </a:solidFill>
                 <a:latin typeface="Calibri"/>
               </a:rPr>
-              <a:t>—  The AI angle is the differentiator: our real rival isn't another app, it's ChatGPT/Gemini. People open an LLM to fix a photo instead of finding a retoucher.</a:t>
+              <a:t>-  The AI angle is the differentiator: our real rival isn't another app, it's ChatGPT/Gemini. People open an LLM to fix a photo instead of finding a retoucher.</a:t>
             </a:r>
           </a:p>
           <a:p>
@@ -7297,7 +7297,7 @@
                 </a:solidFill>
                 <a:latin typeface="Calibri"/>
               </a:rPr>
-              <a:t>·  So we show a purpose-built product that does these exact jobs faster and cleaner than a general AI — 'AI' badges on screenshots, an AI-angle CPP, messaging vs 'just ask an AI'.</a:t>
+              <a:t>·  So we show a purpose-built product that does these exact jobs faster and cleaner than a general AI - 'AI' badges on screenshots, an AI-angle CPP, messaging vs 'just ask an AI'.</a:t>
             </a:r>
           </a:p>
           <a:p>
@@ -7313,7 +7313,7 @@
                 </a:solidFill>
                 <a:latin typeface="Calibri"/>
               </a:rPr>
-              <a:t>—  Halo: paid velocity on a tool term lifts its organic rank → free installs on top.</a:t>
+              <a:t>-  Halo: paid velocity on a tool term lifts its organic rank → free installs on top.</a:t>
             </a:r>
           </a:p>
           <a:p>
@@ -7329,7 +7329,7 @@
                 </a:solidFill>
                 <a:latin typeface="Calibri"/>
               </a:rPr>
-              <a:t>·  Cannibalisation: bidding our own brand partly pays for installs organic already wins — measured, not assumed.</a:t>
+              <a:t>·  Cannibalisation: bidding our own brand partly pays for installs organic already wins - measured, not assumed.</a:t>
             </a:r>
           </a:p>
           <a:p>
@@ -7345,7 +7345,7 @@
                 </a:solidFill>
                 <a:latin typeface="Calibri"/>
               </a:rPr>
-              <a:t>—  Measure paid→organic: rank tracking per keyword (ASO Mobile) before/after push; brand-pause + geo-holdout for incrementality.</a:t>
+              <a:t>-  Measure paid→organic: rank tracking per keyword (ASO Mobile) before/after push; brand-pause + geo-holdout for incrementality.</a:t>
             </a:r>
           </a:p>
           <a:p>
@@ -7361,7 +7361,7 @@
                 </a:solidFill>
                 <a:latin typeface="Calibri"/>
               </a:rPr>
-              <a:t>—  Default listing is an ASO surface: PPO A/B on screenshots/icon lifts install rate for all traffic; tool-CPPs complement it per intent.</a:t>
+              <a:t>-  Default listing is an ASO surface: PPO A/B on screenshots/icon lifts install rate for all traffic; tool-CPPs complement it per intent.</a:t>
             </a:r>
           </a:p>
         </p:txBody>
@@ -7535,7 +7535,7 @@
                 </a:solidFill>
                 <a:latin typeface="Georgia"/>
               </a:rPr>
-              <a:t>A page per intent — including AI</a:t>
+              <a:t>A page per intent - including AI</a:t>
             </a:r>
           </a:p>
         </p:txBody>
@@ -8557,7 +8557,7 @@
                           </a:solidFill>
                           <a:latin typeface="Calibri"/>
                         </a:rPr>
-                        <a:t>—</a:t>
+                        <a:t>-</a:t>
                       </a:r>
                     </a:p>
                   </a:txBody>
@@ -9333,7 +9333,7 @@
                 </a:solidFill>
                 <a:latin typeface="Calibri"/>
               </a:rPr>
-              <a:t>Bidding: keyword-level, derived from a target CPA per geo (CPT = target CPA × CR), moved on downstream trial/payer — not installs. Brand capped at real CPT.</a:t>
+              <a:t>Bidding: keyword-level, derived from a target CPA per geo (CPT = target CPA × CR), moved on downstream trial/payer - not installs. Brand capped at real CPT.</a:t>
             </a:r>
           </a:p>
           <a:p>
@@ -9606,7 +9606,7 @@
                 </a:solidFill>
                 <a:latin typeface="Calibri"/>
               </a:rPr>
-              <a:t>—  Why console shows ~30% more than MMP: AdServices counts redownloads + view-through on its own window; AppsFlyer dedupes, drops ATT/SKAN-null installs, needs SDK first-open.</a:t>
+              <a:t>-  Why console shows ~30% more than MMP: AdServices counts redownloads + view-through on its own window; AppsFlyer dedupes, drops ATT/SKAN-null installs, needs SDK first-open.</a:t>
             </a:r>
           </a:p>
           <a:p>
@@ -9622,7 +9622,7 @@
                 </a:solidFill>
                 <a:latin typeface="Calibri"/>
               </a:rPr>
-              <a:t>—  Reconcile: one attribution window; AdServices API = source of truth for ASA installs (deterministic, survives ATT); documented console→MMP bridge, tracked weekly.</a:t>
+              <a:t>-  Reconcile: one attribution window; AdServices API = source of truth for ASA installs (deterministic, survives ATT); documented console→MMP bridge, tracked weekly.</a:t>
             </a:r>
           </a:p>
           <a:p>
@@ -9686,7 +9686,7 @@
                 </a:solidFill>
                 <a:latin typeface="Calibri"/>
               </a:rPr>
-              <a:t>—  Under ATT: AdServices deterministic for ASA installs; SKAN conversion values for downstream (non-ATT); predictive for revenue where SKAN is null.</a:t>
+              <a:t>-  Under ATT: AdServices deterministic for ASA installs; SKAN conversion values for downstream (non-ATT); predictive for revenue where SKAN is null.</a:t>
             </a:r>
           </a:p>
           <a:p>
@@ -9702,7 +9702,7 @@
                 </a:solidFill>
                 <a:latin typeface="Calibri"/>
               </a:rPr>
-              <a:t>—  Weekly KPIs: Spend, TTR, CR, CPT, CPI, installs (console vs MMP Δ%), CPA(trial), CPA(payer), Trial→Paid%, ROAS (D7 lead + D30 gate), organic rank of top tool terms, organic install share.</a:t>
+              <a:t>-  Weekly KPIs: Spend, TTR, CR, CPT, CPI, installs (console vs MMP Δ%), CPA(trial), CPA(payer), Trial→Paid%, ROAS (D7 lead + D30 gate), organic rank of top tool terms, organic install share.</a:t>
             </a:r>
           </a:p>
         </p:txBody>
@@ -10073,7 +10073,7 @@
                           </a:solidFill>
                           <a:latin typeface="Calibri"/>
                         </a:rPr>
-                        <a:t>Organic backfills ≥70% → cut permanently / Kill: organic −&gt;30%</a:t>
+                        <a:t>Organic backfills ≥70% → cut permanently / Kill: organic drops &gt;30%</a:t>
                       </a:r>
                     </a:p>
                   </a:txBody>
@@ -10209,7 +10209,7 @@
                           </a:solidFill>
                           <a:latin typeface="Calibri"/>
                         </a:rPr>
-                        <a:t>CPA −15% at equal volume / Kill: volume −&gt;20%</a:t>
+                        <a:t>CPA -15% at equal volume / Kill: volume drops &gt;20%</a:t>
                       </a:r>
                     </a:p>
                   </a:txBody>

</xml_diff>